<commit_message>
fix(docs): ADLC PPTX label anchors, flat shapes, metadata
Co-Authored-By: Claude Opus 5.5 <noreply@anthropic.com>
</commit_message>
<xml_diff>
--- a/docs/presentations/adlc.pptx
+++ b/docs/presentations/adlc.pptx
@@ -3134,6 +3134,7 @@
               <a:srgbClr val="B4530B"/>
             </a:solidFill>
           </a:ln>
+          <a:effectLst/>
         </p:spPr>
         <p:style>
           <a:lnRef idx="1">
@@ -3181,6 +3182,7 @@
             <a:avLst/>
           </a:prstGeom>
           <a:noFill/>
+          <a:effectLst/>
         </p:spPr>
         <p:txBody>
           <a:bodyPr wrap="square" lIns="0" rIns="0" tIns="0" bIns="0">
@@ -3238,6 +3240,7 @@
               <a:srgbClr val="2B55C7"/>
             </a:solidFill>
           </a:ln>
+          <a:effectLst/>
         </p:spPr>
         <p:style>
           <a:lnRef idx="1">
@@ -3357,6 +3360,7 @@
             <a:avLst/>
           </a:prstGeom>
           <a:noFill/>
+          <a:effectLst/>
         </p:spPr>
         <p:txBody>
           <a:bodyPr wrap="none">
@@ -3417,6 +3421,7 @@
             <a:avLst/>
           </a:prstGeom>
           <a:noFill/>
+          <a:effectLst/>
         </p:spPr>
         <p:txBody>
           <a:bodyPr wrap="square" lIns="0" tIns="0" rIns="0" bIns="0">
@@ -3474,6 +3479,7 @@
               <a:srgbClr val="CFD6DF"/>
             </a:solidFill>
           </a:ln>
+          <a:effectLst/>
         </p:spPr>
         <p:style>
           <a:lnRef idx="1">
@@ -3607,6 +3613,7 @@
               <a:srgbClr val="CFD6DF"/>
             </a:solidFill>
           </a:ln>
+          <a:effectLst/>
         </p:spPr>
         <p:style>
           <a:lnRef idx="1">
@@ -4158,6 +4165,7 @@
               <a:srgbClr val="B4530B"/>
             </a:solidFill>
           </a:ln>
+          <a:effectLst/>
         </p:spPr>
         <p:style>
           <a:lnRef idx="1">
@@ -4231,6 +4239,7 @@
             <a:avLst/>
           </a:prstGeom>
           <a:noFill/>
+          <a:effectLst/>
         </p:spPr>
         <p:txBody>
           <a:bodyPr wrap="square" lIns="0" tIns="0" rIns="0" bIns="0">
@@ -4288,6 +4297,7 @@
               <a:srgbClr val="CFD6DF"/>
             </a:solidFill>
           </a:ln>
+          <a:effectLst/>
         </p:spPr>
         <p:style>
           <a:lnRef idx="1">
@@ -4446,6 +4456,7 @@
               <a:srgbClr val="CFD6DF"/>
             </a:solidFill>
           </a:ln>
+          <a:effectLst/>
         </p:spPr>
         <p:style>
           <a:lnRef idx="1">
@@ -4604,6 +4615,7 @@
               <a:srgbClr val="B4530B"/>
             </a:solidFill>
           </a:ln>
+          <a:effectLst/>
         </p:spPr>
         <p:style>
           <a:lnRef idx="1">
@@ -4667,6 +4679,7 @@
               <a:srgbClr val="2B55C7"/>
             </a:solidFill>
           </a:ln>
+          <a:effectLst/>
         </p:spPr>
         <p:style>
           <a:lnRef idx="1">
@@ -4749,6 +4762,7 @@
             <a:avLst/>
           </a:prstGeom>
           <a:noFill/>
+          <a:effectLst/>
         </p:spPr>
         <p:txBody>
           <a:bodyPr wrap="square" lIns="0" tIns="0" rIns="0" bIns="0">
@@ -4806,6 +4820,7 @@
               <a:srgbClr val="CFD6DF"/>
             </a:solidFill>
           </a:ln>
+          <a:effectLst/>
         </p:spPr>
         <p:style>
           <a:lnRef idx="1">
@@ -4989,6 +5004,7 @@
               <a:srgbClr val="CFD6DF"/>
             </a:solidFill>
           </a:ln>
+          <a:effectLst/>
         </p:spPr>
         <p:style>
           <a:lnRef idx="1">
@@ -5166,6 +5182,7 @@
             <a:avLst/>
           </a:prstGeom>
           <a:noFill/>
+          <a:effectLst/>
         </p:spPr>
         <p:txBody>
           <a:bodyPr wrap="square" lIns="0" tIns="0" rIns="0" bIns="0">
@@ -5223,6 +5240,7 @@
               <a:srgbClr val="CFD6DF"/>
             </a:solidFill>
           </a:ln>
+          <a:effectLst/>
         </p:spPr>
         <p:style>
           <a:lnRef idx="1">
@@ -5381,6 +5399,7 @@
               <a:srgbClr val="CFD6DF"/>
             </a:solidFill>
           </a:ln>
+          <a:effectLst/>
         </p:spPr>
         <p:style>
           <a:lnRef idx="1">
@@ -5558,6 +5577,7 @@
             <a:avLst/>
           </a:prstGeom>
           <a:noFill/>
+          <a:effectLst/>
         </p:spPr>
         <p:txBody>
           <a:bodyPr wrap="square" lIns="0" tIns="0" rIns="0" bIns="0">
@@ -5615,6 +5635,7 @@
               <a:srgbClr val="CFD6DF"/>
             </a:solidFill>
           </a:ln>
+          <a:effectLst/>
         </p:spPr>
         <p:style>
           <a:lnRef idx="1">
@@ -5689,6 +5710,7 @@
               <a:srgbClr val="CFD6DF"/>
             </a:solidFill>
           </a:ln>
+          <a:effectLst/>
         </p:spPr>
         <p:style>
           <a:lnRef idx="1">
@@ -5763,6 +5785,7 @@
               <a:srgbClr val="CFD6DF"/>
             </a:solidFill>
           </a:ln>
+          <a:effectLst/>
         </p:spPr>
         <p:style>
           <a:lnRef idx="1">
@@ -5837,6 +5860,7 @@
               <a:srgbClr val="2B55C7"/>
             </a:solidFill>
           </a:ln>
+          <a:effectLst/>
         </p:spPr>
         <p:style>
           <a:lnRef idx="1">
@@ -5919,6 +5943,7 @@
             <a:avLst/>
           </a:prstGeom>
           <a:noFill/>
+          <a:effectLst/>
         </p:spPr>
         <p:txBody>
           <a:bodyPr wrap="square" lIns="0" tIns="0" rIns="0" bIns="0">
@@ -5976,6 +6001,7 @@
               <a:srgbClr val="CFD6DF"/>
             </a:solidFill>
           </a:ln>
+          <a:effectLst/>
         </p:spPr>
         <p:style>
           <a:lnRef idx="1">
@@ -6134,6 +6160,7 @@
               <a:srgbClr val="CFD6DF"/>
             </a:solidFill>
           </a:ln>
+          <a:effectLst/>
         </p:spPr>
         <p:style>
           <a:lnRef idx="1">
@@ -6311,6 +6338,7 @@
             <a:avLst/>
           </a:prstGeom>
           <a:noFill/>
+          <a:effectLst/>
         </p:spPr>
         <p:txBody>
           <a:bodyPr wrap="square" lIns="0" tIns="0" rIns="0" bIns="0">
@@ -6368,6 +6396,7 @@
               <a:srgbClr val="2B55C7"/>
             </a:solidFill>
           </a:ln>
+          <a:effectLst/>
         </p:spPr>
         <p:style>
           <a:lnRef idx="1">
@@ -6450,6 +6479,7 @@
               <a:srgbClr val="141C26"/>
             </a:solidFill>
           </a:ln>
+          <a:effectLst/>
         </p:spPr>
         <p:style>
           <a:lnRef idx="1">
@@ -6532,6 +6562,7 @@
               <a:srgbClr val="CFD6DF"/>
             </a:solidFill>
           </a:ln>
+          <a:effectLst/>
         </p:spPr>
         <p:style>
           <a:lnRef idx="1">
@@ -6602,6 +6633,7 @@
               <a:srgbClr val="B4530B"/>
             </a:solidFill>
           </a:ln>
+          <a:effectLst/>
         </p:spPr>
         <p:style>
           <a:lnRef idx="1">
@@ -6670,6 +6702,7 @@
             </a:solidFill>
             <a:tailEnd type="triangle"/>
           </a:ln>
+          <a:effectLst/>
         </p:spPr>
         <p:style>
           <a:lnRef idx="2">
@@ -6694,13 +6727,14 @@
         </p:nvSpPr>
         <p:spPr>
           <a:xfrm>
-            <a:off x="5700000" y="4410000"/>
-            <a:ext cx="912000" cy="336000"/>
+            <a:off x="5967088" y="4480000"/>
+            <a:ext cx="377825" cy="224000"/>
           </a:xfrm>
           <a:prstGeom prst="rect">
             <a:avLst/>
           </a:prstGeom>
           <a:noFill/>
+          <a:effectLst/>
         </p:spPr>
         <p:txBody>
           <a:bodyPr wrap="none" lIns="0" rIns="0" tIns="0" bIns="0">
@@ -6741,6 +6775,7 @@
             </a:solidFill>
             <a:tailEnd type="triangle"/>
           </a:ln>
+          <a:effectLst/>
         </p:spPr>
         <p:style>
           <a:lnRef idx="2">
@@ -6765,13 +6800,14 @@
         </p:nvSpPr>
         <p:spPr>
           <a:xfrm>
-            <a:off x="3591000" y="3430000"/>
-            <a:ext cx="912000" cy="336000"/>
+            <a:off x="3876000" y="3500000"/>
+            <a:ext cx="431800" cy="224000"/>
           </a:xfrm>
           <a:prstGeom prst="rect">
             <a:avLst/>
           </a:prstGeom>
           <a:noFill/>
+          <a:effectLst/>
         </p:spPr>
         <p:txBody>
           <a:bodyPr wrap="none" lIns="0" rIns="0" tIns="0" bIns="0">
@@ -6779,7 +6815,7 @@
           </a:bodyPr>
           <a:lstStyle/>
           <a:p>
-            <a:pPr algn="ctr"/>
+            <a:pPr algn="l"/>
             <a:r>
               <a:rPr sz="850">
                 <a:solidFill>
@@ -6812,6 +6848,7 @@
             </a:solidFill>
             <a:tailEnd type="triangle"/>
           </a:ln>
+          <a:effectLst/>
         </p:spPr>
         <p:style>
           <a:lnRef idx="2">
@@ -6836,13 +6873,14 @@
         </p:nvSpPr>
         <p:spPr>
           <a:xfrm>
-            <a:off x="8379000" y="3430000"/>
-            <a:ext cx="912000" cy="336000"/>
+            <a:off x="8664000" y="3500000"/>
+            <a:ext cx="431800" cy="224000"/>
           </a:xfrm>
           <a:prstGeom prst="rect">
             <a:avLst/>
           </a:prstGeom>
           <a:noFill/>
+          <a:effectLst/>
         </p:spPr>
         <p:txBody>
           <a:bodyPr wrap="none" lIns="0" rIns="0" tIns="0" bIns="0">
@@ -6850,7 +6888,7 @@
           </a:bodyPr>
           <a:lstStyle/>
           <a:p>
-            <a:pPr algn="ctr"/>
+            <a:pPr algn="l"/>
             <a:r>
               <a:rPr sz="850">
                 <a:solidFill>
@@ -6883,6 +6921,7 @@
             </a:solidFill>
             <a:tailEnd type="triangle"/>
           </a:ln>
+          <a:effectLst/>
         </p:spPr>
         <p:style>
           <a:lnRef idx="2">
@@ -6907,13 +6946,14 @@
         </p:nvSpPr>
         <p:spPr>
           <a:xfrm>
-            <a:off x="5472000" y="3290000"/>
-            <a:ext cx="912000" cy="336000"/>
+            <a:off x="5712100" y="3360000"/>
+            <a:ext cx="431800" cy="224000"/>
           </a:xfrm>
           <a:prstGeom prst="rect">
             <a:avLst/>
           </a:prstGeom>
           <a:noFill/>
+          <a:effectLst/>
         </p:spPr>
         <p:txBody>
           <a:bodyPr wrap="none" lIns="0" rIns="0" tIns="0" bIns="0">
@@ -6975,6 +7015,7 @@
             <a:avLst/>
           </a:prstGeom>
           <a:noFill/>
+          <a:effectLst/>
         </p:spPr>
         <p:txBody>
           <a:bodyPr wrap="square" lIns="0" tIns="0" rIns="0" bIns="0">
@@ -7032,6 +7073,7 @@
               <a:srgbClr val="CFD6DF"/>
             </a:solidFill>
           </a:ln>
+          <a:effectLst/>
         </p:spPr>
         <p:style>
           <a:lnRef idx="1">
@@ -7106,6 +7148,7 @@
               <a:srgbClr val="CFD6DF"/>
             </a:solidFill>
           </a:ln>
+          <a:effectLst/>
         </p:spPr>
         <p:style>
           <a:lnRef idx="1">
@@ -7153,6 +7196,7 @@
             <a:avLst/>
           </a:prstGeom>
           <a:noFill/>
+          <a:effectLst/>
         </p:spPr>
         <p:txBody>
           <a:bodyPr wrap="square" lIns="0" rIns="0" tIns="0" bIns="0">
@@ -7194,6 +7238,7 @@
               <a:srgbClr val="CFD6DF"/>
             </a:solidFill>
           </a:ln>
+          <a:effectLst/>
         </p:spPr>
         <p:style>
           <a:lnRef idx="1">
@@ -7377,6 +7422,7 @@
               <a:srgbClr val="CFD6DF"/>
             </a:solidFill>
           </a:ln>
+          <a:effectLst/>
         </p:spPr>
         <p:style>
           <a:lnRef idx="1">
@@ -7510,6 +7556,7 @@
             <a:avLst/>
           </a:prstGeom>
           <a:noFill/>
+          <a:effectLst/>
         </p:spPr>
         <p:txBody>
           <a:bodyPr wrap="square" lIns="0" tIns="0" rIns="0" bIns="0">
@@ -7567,6 +7614,7 @@
               <a:srgbClr val="CFD6DF"/>
             </a:solidFill>
           </a:ln>
+          <a:effectLst/>
         </p:spPr>
         <p:style>
           <a:lnRef idx="1">
@@ -7641,6 +7689,7 @@
               <a:srgbClr val="CFD6DF"/>
             </a:solidFill>
           </a:ln>
+          <a:effectLst/>
         </p:spPr>
         <p:style>
           <a:lnRef idx="1">
@@ -7715,6 +7764,7 @@
               <a:srgbClr val="CFD6DF"/>
             </a:solidFill>
           </a:ln>
+          <a:effectLst/>
         </p:spPr>
         <p:style>
           <a:lnRef idx="1">
@@ -7789,6 +7839,7 @@
               <a:srgbClr val="B4530B"/>
             </a:solidFill>
           </a:ln>
+          <a:effectLst/>
         </p:spPr>
         <p:style>
           <a:lnRef idx="1">
@@ -7871,6 +7922,7 @@
             <a:avLst/>
           </a:prstGeom>
           <a:noFill/>
+          <a:effectLst/>
         </p:spPr>
         <p:txBody>
           <a:bodyPr wrap="square" lIns="0" tIns="0" rIns="0" bIns="0">
@@ -7926,6 +7978,7 @@
           <a:ln>
             <a:noFill/>
           </a:ln>
+          <a:effectLst/>
         </p:spPr>
         <p:style>
           <a:lnRef idx="1">
@@ -7969,6 +8022,7 @@
           <a:ln>
             <a:noFill/>
           </a:ln>
+          <a:effectLst/>
         </p:spPr>
         <p:style>
           <a:lnRef idx="1">
@@ -8012,6 +8066,7 @@
           <a:ln>
             <a:noFill/>
           </a:ln>
+          <a:effectLst/>
         </p:spPr>
         <p:style>
           <a:lnRef idx="1">
@@ -8055,6 +8110,7 @@
           <a:ln>
             <a:noFill/>
           </a:ln>
+          <a:effectLst/>
         </p:spPr>
         <p:style>
           <a:lnRef idx="1">
@@ -8098,6 +8154,7 @@
           <a:ln>
             <a:noFill/>
           </a:ln>
+          <a:effectLst/>
         </p:spPr>
         <p:style>
           <a:lnRef idx="1">
@@ -8141,6 +8198,7 @@
           <a:ln>
             <a:noFill/>
           </a:ln>
+          <a:effectLst/>
         </p:spPr>
         <p:style>
           <a:lnRef idx="1">
@@ -8183,6 +8241,7 @@
               <a:srgbClr val="CFD6DF"/>
             </a:solidFill>
           </a:ln>
+          <a:effectLst/>
         </p:spPr>
         <p:style>
           <a:lnRef idx="2">
@@ -8218,6 +8277,7 @@
               <a:srgbClr val="CFD6DF"/>
             </a:solidFill>
           </a:ln>
+          <a:effectLst/>
         </p:spPr>
         <p:style>
           <a:lnRef idx="2">
@@ -8253,6 +8313,7 @@
               <a:srgbClr val="CFD6DF"/>
             </a:solidFill>
           </a:ln>
+          <a:effectLst/>
         </p:spPr>
         <p:style>
           <a:lnRef idx="2">
@@ -8288,6 +8349,7 @@
               <a:srgbClr val="CFD6DF"/>
             </a:solidFill>
           </a:ln>
+          <a:effectLst/>
         </p:spPr>
         <p:style>
           <a:lnRef idx="2">
@@ -8323,6 +8385,7 @@
               <a:srgbClr val="CFD6DF"/>
             </a:solidFill>
           </a:ln>
+          <a:effectLst/>
         </p:spPr>
         <p:style>
           <a:lnRef idx="2">
@@ -8358,6 +8421,7 @@
               <a:srgbClr val="CFD6DF"/>
             </a:solidFill>
           </a:ln>
+          <a:effectLst/>
         </p:spPr>
         <p:style>
           <a:lnRef idx="2">
@@ -8393,6 +8457,7 @@
               <a:srgbClr val="CFD6DF"/>
             </a:solidFill>
           </a:ln>
+          <a:effectLst/>
         </p:spPr>
         <p:style>
           <a:lnRef idx="2">
@@ -8428,6 +8493,7 @@
               <a:srgbClr val="CFD6DF"/>
             </a:solidFill>
           </a:ln>
+          <a:effectLst/>
         </p:spPr>
         <p:style>
           <a:lnRef idx="2">
@@ -8463,6 +8529,7 @@
               <a:srgbClr val="CFD6DF"/>
             </a:solidFill>
           </a:ln>
+          <a:effectLst/>
         </p:spPr>
         <p:style>
           <a:lnRef idx="2">
@@ -8499,6 +8566,7 @@
             </a:solidFill>
             <a:prstDash val="dash"/>
           </a:ln>
+          <a:effectLst/>
         </p:spPr>
         <p:style>
           <a:lnRef idx="2">
@@ -8535,6 +8603,7 @@
             </a:solidFill>
             <a:prstDash val="dash"/>
           </a:ln>
+          <a:effectLst/>
         </p:spPr>
         <p:style>
           <a:lnRef idx="2">
@@ -8571,6 +8640,7 @@
             </a:solidFill>
             <a:prstDash val="dash"/>
           </a:ln>
+          <a:effectLst/>
         </p:spPr>
         <p:style>
           <a:lnRef idx="2">
@@ -8607,6 +8677,7 @@
             </a:solidFill>
             <a:prstDash val="dash"/>
           </a:ln>
+          <a:effectLst/>
         </p:spPr>
         <p:style>
           <a:lnRef idx="2">
@@ -8643,6 +8714,7 @@
             </a:solidFill>
             <a:prstDash val="dash"/>
           </a:ln>
+          <a:effectLst/>
         </p:spPr>
         <p:style>
           <a:lnRef idx="2">
@@ -8674,6 +8746,7 @@
             <a:avLst/>
           </a:prstGeom>
           <a:noFill/>
+          <a:effectLst/>
         </p:spPr>
         <p:txBody>
           <a:bodyPr wrap="none" lIns="0" rIns="0" tIns="0" bIns="0">
@@ -8709,6 +8782,7 @@
             <a:avLst/>
           </a:prstGeom>
           <a:noFill/>
+          <a:effectLst/>
         </p:spPr>
         <p:txBody>
           <a:bodyPr wrap="none" lIns="0" rIns="0" tIns="0" bIns="0">
@@ -8744,6 +8818,7 @@
             <a:avLst/>
           </a:prstGeom>
           <a:noFill/>
+          <a:effectLst/>
         </p:spPr>
         <p:txBody>
           <a:bodyPr wrap="none" lIns="0" rIns="0" tIns="0" bIns="0">
@@ -8779,6 +8854,7 @@
             <a:avLst/>
           </a:prstGeom>
           <a:noFill/>
+          <a:effectLst/>
         </p:spPr>
         <p:txBody>
           <a:bodyPr wrap="none" lIns="0" rIns="0" tIns="0" bIns="0">
@@ -8814,6 +8890,7 @@
             <a:avLst/>
           </a:prstGeom>
           <a:noFill/>
+          <a:effectLst/>
         </p:spPr>
         <p:txBody>
           <a:bodyPr wrap="none" lIns="0" rIns="0" tIns="0" bIns="0">
@@ -8849,6 +8926,7 @@
             <a:avLst/>
           </a:prstGeom>
           <a:noFill/>
+          <a:effectLst/>
         </p:spPr>
         <p:txBody>
           <a:bodyPr wrap="none" lIns="0" rIns="0" tIns="0" bIns="0">
@@ -8894,6 +8972,7 @@
             <a:avLst/>
           </a:prstGeom>
           <a:noFill/>
+          <a:effectLst/>
         </p:spPr>
         <p:txBody>
           <a:bodyPr wrap="none" lIns="0" rIns="0" tIns="0" bIns="0">
@@ -8939,6 +9018,7 @@
             <a:avLst/>
           </a:prstGeom>
           <a:noFill/>
+          <a:effectLst/>
         </p:spPr>
         <p:txBody>
           <a:bodyPr wrap="none" lIns="0" rIns="0" tIns="0" bIns="0">
@@ -8984,6 +9064,7 @@
             <a:avLst/>
           </a:prstGeom>
           <a:noFill/>
+          <a:effectLst/>
         </p:spPr>
         <p:txBody>
           <a:bodyPr wrap="none" lIns="0" rIns="0" tIns="0" bIns="0">
@@ -9029,6 +9110,7 @@
             <a:avLst/>
           </a:prstGeom>
           <a:noFill/>
+          <a:effectLst/>
         </p:spPr>
         <p:txBody>
           <a:bodyPr wrap="none" lIns="0" rIns="0" tIns="0" bIns="0">
@@ -9074,6 +9156,7 @@
             <a:avLst/>
           </a:prstGeom>
           <a:noFill/>
+          <a:effectLst/>
         </p:spPr>
         <p:txBody>
           <a:bodyPr wrap="none" lIns="0" rIns="0" tIns="0" bIns="0">
@@ -9119,6 +9202,7 @@
             <a:avLst/>
           </a:prstGeom>
           <a:noFill/>
+          <a:effectLst/>
         </p:spPr>
         <p:txBody>
           <a:bodyPr wrap="none" lIns="0" rIns="0" tIns="0" bIns="0">
@@ -9164,6 +9248,7 @@
             <a:avLst/>
           </a:prstGeom>
           <a:noFill/>
+          <a:effectLst/>
         </p:spPr>
         <p:txBody>
           <a:bodyPr wrap="none" lIns="0" rIns="0" tIns="0" bIns="0">
@@ -9216,6 +9301,7 @@
               <a:srgbClr val="141C26"/>
             </a:solidFill>
           </a:ln>
+          <a:effectLst/>
         </p:spPr>
         <p:style>
           <a:lnRef idx="1">
@@ -9268,6 +9354,7 @@
             </a:solidFill>
             <a:tailEnd type="triangle"/>
           </a:ln>
+          <a:effectLst/>
         </p:spPr>
         <p:style>
           <a:lnRef idx="2">
@@ -9292,13 +9379,14 @@
         </p:nvSpPr>
         <p:spPr>
           <a:xfrm>
-            <a:off x="1938000" y="3460500"/>
-            <a:ext cx="840000" cy="146000"/>
+            <a:off x="2147850" y="3482400"/>
+            <a:ext cx="285750" cy="102200"/>
           </a:xfrm>
           <a:prstGeom prst="rect">
             <a:avLst/>
           </a:prstGeom>
           <a:noFill/>
+          <a:effectLst/>
         </p:spPr>
         <p:txBody>
           <a:bodyPr wrap="none" lIns="0" rIns="0" tIns="0" bIns="0">
@@ -9341,6 +9429,7 @@
               <a:srgbClr val="2B55C7"/>
             </a:solidFill>
           </a:ln>
+          <a:effectLst/>
         </p:spPr>
         <p:style>
           <a:lnRef idx="1">
@@ -9407,6 +9496,7 @@
               <a:srgbClr val="B4530B"/>
             </a:solidFill>
           </a:ln>
+          <a:effectLst/>
         </p:spPr>
         <p:style>
           <a:lnRef idx="1">
@@ -9459,6 +9549,7 @@
             </a:solidFill>
             <a:tailEnd type="triangle"/>
           </a:ln>
+          <a:effectLst/>
         </p:spPr>
         <p:style>
           <a:lnRef idx="2">
@@ -9483,13 +9574,14 @@
         </p:nvSpPr>
         <p:spPr>
           <a:xfrm>
-            <a:off x="3072000" y="3460500"/>
-            <a:ext cx="840000" cy="146000"/>
+            <a:off x="3290400" y="3482400"/>
+            <a:ext cx="714375" cy="102200"/>
           </a:xfrm>
           <a:prstGeom prst="rect">
             <a:avLst/>
           </a:prstGeom>
           <a:noFill/>
+          <a:effectLst/>
         </p:spPr>
         <p:txBody>
           <a:bodyPr wrap="none" lIns="0" rIns="0" tIns="0" bIns="0">
@@ -9532,6 +9624,7 @@
               <a:srgbClr val="141C26"/>
             </a:solidFill>
           </a:ln>
+          <a:effectLst/>
         </p:spPr>
         <p:style>
           <a:lnRef idx="1">
@@ -9584,6 +9677,7 @@
             </a:solidFill>
             <a:tailEnd type="triangle"/>
           </a:ln>
+          <a:effectLst/>
         </p:spPr>
         <p:style>
           <a:lnRef idx="2">
@@ -9622,6 +9716,7 @@
               <a:srgbClr val="2B55C7"/>
             </a:solidFill>
           </a:ln>
+          <a:effectLst/>
         </p:spPr>
         <p:style>
           <a:lnRef idx="1">
@@ -9688,6 +9783,7 @@
               <a:srgbClr val="B4530B"/>
             </a:solidFill>
           </a:ln>
+          <a:effectLst/>
         </p:spPr>
         <p:style>
           <a:lnRef idx="1">
@@ -9740,6 +9836,7 @@
             </a:solidFill>
             <a:tailEnd type="triangle"/>
           </a:ln>
+          <a:effectLst/>
         </p:spPr>
         <p:style>
           <a:lnRef idx="2">
@@ -9764,13 +9861,14 @@
         </p:nvSpPr>
         <p:spPr>
           <a:xfrm>
-            <a:off x="4668000" y="3460500"/>
-            <a:ext cx="840000" cy="146000"/>
+            <a:off x="4970400" y="3482400"/>
+            <a:ext cx="190500" cy="102200"/>
           </a:xfrm>
           <a:prstGeom prst="rect">
             <a:avLst/>
           </a:prstGeom>
           <a:noFill/>
+          <a:effectLst/>
         </p:spPr>
         <p:txBody>
           <a:bodyPr wrap="none" lIns="0" rIns="0" tIns="0" bIns="0">
@@ -9813,6 +9911,7 @@
               <a:srgbClr val="141C26"/>
             </a:solidFill>
           </a:ln>
+          <a:effectLst/>
         </p:spPr>
         <p:style>
           <a:lnRef idx="1">
@@ -9865,6 +9964,7 @@
             </a:solidFill>
             <a:tailEnd type="triangle"/>
           </a:ln>
+          <a:effectLst/>
         </p:spPr>
         <p:style>
           <a:lnRef idx="2">
@@ -9903,6 +10003,7 @@
               <a:srgbClr val="2B55C7"/>
             </a:solidFill>
           </a:ln>
+          <a:effectLst/>
         </p:spPr>
         <p:style>
           <a:lnRef idx="1">
@@ -9969,6 +10070,7 @@
               <a:srgbClr val="141C26"/>
             </a:solidFill>
           </a:ln>
+          <a:effectLst/>
         </p:spPr>
         <p:style>
           <a:lnRef idx="1">
@@ -10021,6 +10123,7 @@
             </a:solidFill>
             <a:tailEnd type="triangle"/>
           </a:ln>
+          <a:effectLst/>
         </p:spPr>
         <p:style>
           <a:lnRef idx="2">
@@ -10045,13 +10148,14 @@
         </p:nvSpPr>
         <p:spPr>
           <a:xfrm>
-            <a:off x="6096000" y="3460500"/>
-            <a:ext cx="840000" cy="146000"/>
+            <a:off x="6339450" y="3482400"/>
+            <a:ext cx="285750" cy="102200"/>
           </a:xfrm>
           <a:prstGeom prst="rect">
             <a:avLst/>
           </a:prstGeom>
           <a:noFill/>
+          <a:effectLst/>
         </p:spPr>
         <p:txBody>
           <a:bodyPr wrap="none" lIns="0" rIns="0" tIns="0" bIns="0">
@@ -10094,6 +10198,7 @@
               <a:srgbClr val="141C26"/>
             </a:solidFill>
           </a:ln>
+          <a:effectLst/>
         </p:spPr>
         <p:style>
           <a:lnRef idx="1">
@@ -10146,6 +10251,7 @@
             </a:solidFill>
             <a:tailEnd type="triangle"/>
           </a:ln>
+          <a:effectLst/>
         </p:spPr>
         <p:style>
           <a:lnRef idx="2">
@@ -10185,6 +10291,7 @@
             </a:solidFill>
             <a:prstDash val="dash"/>
           </a:ln>
+          <a:effectLst/>
         </p:spPr>
         <p:style>
           <a:lnRef idx="1">
@@ -10251,6 +10358,7 @@
               <a:srgbClr val="2B55C7"/>
             </a:solidFill>
           </a:ln>
+          <a:effectLst/>
         </p:spPr>
         <p:style>
           <a:lnRef idx="1">
@@ -10315,6 +10423,7 @@
             </a:solidFill>
             <a:tailEnd type="triangle"/>
           </a:ln>
+          <a:effectLst/>
         </p:spPr>
         <p:style>
           <a:lnRef idx="2">
@@ -10353,6 +10462,7 @@
               <a:srgbClr val="2B55C7"/>
             </a:solidFill>
           </a:ln>
+          <a:effectLst/>
         </p:spPr>
         <p:style>
           <a:lnRef idx="1">
@@ -10417,6 +10527,7 @@
             </a:solidFill>
             <a:tailEnd type="triangle"/>
           </a:ln>
+          <a:effectLst/>
         </p:spPr>
         <p:style>
           <a:lnRef idx="2">
@@ -10456,6 +10567,7 @@
             </a:solidFill>
             <a:prstDash val="dash"/>
           </a:ln>
+          <a:effectLst/>
         </p:spPr>
         <p:style>
           <a:lnRef idx="1">
@@ -10519,6 +10631,7 @@
               <a:srgbClr val="141C26"/>
             </a:solidFill>
           </a:ln>
+          <a:effectLst/>
         </p:spPr>
         <p:style>
           <a:lnRef idx="2">
@@ -10555,6 +10668,7 @@
             </a:solidFill>
             <a:tailEnd type="triangle"/>
           </a:ln>
+          <a:effectLst/>
         </p:spPr>
         <p:style>
           <a:lnRef idx="2">
@@ -10579,13 +10693,14 @@
         </p:nvSpPr>
         <p:spPr>
           <a:xfrm>
-            <a:off x="8112000" y="4336500"/>
-            <a:ext cx="840000" cy="146000"/>
+            <a:off x="8414400" y="4329200"/>
+            <a:ext cx="285750" cy="102200"/>
           </a:xfrm>
           <a:prstGeom prst="rect">
             <a:avLst/>
           </a:prstGeom>
           <a:noFill/>
+          <a:effectLst/>
         </p:spPr>
         <p:txBody>
           <a:bodyPr wrap="none" lIns="0" rIns="0" tIns="0" bIns="0">
@@ -10593,7 +10708,7 @@
           </a:bodyPr>
           <a:lstStyle/>
           <a:p>
-            <a:pPr algn="ctr"/>
+            <a:pPr algn="l"/>
             <a:r>
               <a:rPr sz="750">
                 <a:solidFill>
@@ -10626,6 +10741,7 @@
             </a:solidFill>
             <a:tailEnd type="triangle"/>
           </a:ln>
+          <a:effectLst/>
         </p:spPr>
         <p:style>
           <a:lnRef idx="2">
@@ -10650,13 +10766,14 @@
         </p:nvSpPr>
         <p:spPr>
           <a:xfrm>
-            <a:off x="8406000" y="4650400"/>
-            <a:ext cx="840000" cy="146000"/>
+            <a:off x="8615850" y="4716100"/>
+            <a:ext cx="285750" cy="80300"/>
           </a:xfrm>
           <a:prstGeom prst="rect">
             <a:avLst/>
           </a:prstGeom>
           <a:noFill/>
+          <a:effectLst/>
         </p:spPr>
         <p:txBody>
           <a:bodyPr wrap="none" lIns="0" rIns="0" tIns="0" bIns="0">
@@ -10699,6 +10816,7 @@
               <a:srgbClr val="2B55C7"/>
             </a:solidFill>
           </a:ln>
+          <a:effectLst/>
         </p:spPr>
         <p:style>
           <a:lnRef idx="1">
@@ -10763,6 +10881,7 @@
             </a:solidFill>
             <a:tailEnd type="triangle"/>
           </a:ln>
+          <a:effectLst/>
         </p:spPr>
         <p:style>
           <a:lnRef idx="2">
@@ -10787,13 +10906,14 @@
         </p:nvSpPr>
         <p:spPr>
           <a:xfrm>
-            <a:off x="9120000" y="4650400"/>
-            <a:ext cx="840000" cy="146000"/>
+            <a:off x="9422400" y="4716100"/>
+            <a:ext cx="333375" cy="80300"/>
           </a:xfrm>
           <a:prstGeom prst="rect">
             <a:avLst/>
           </a:prstGeom>
           <a:noFill/>
+          <a:effectLst/>
         </p:spPr>
         <p:txBody>
           <a:bodyPr wrap="none" lIns="0" rIns="0" tIns="0" bIns="0">
@@ -10835,6 +10955,7 @@
             <a:tailEnd type="triangle"/>
             <a:prstDash val="dash"/>
           </a:ln>
+          <a:effectLst/>
         </p:spPr>
         <p:style>
           <a:lnRef idx="2">
@@ -10859,13 +10980,14 @@
         </p:nvSpPr>
         <p:spPr>
           <a:xfrm>
-            <a:off x="6919200" y="5103000"/>
-            <a:ext cx="840000" cy="146000"/>
+            <a:off x="7238400" y="5197900"/>
+            <a:ext cx="285750" cy="80300"/>
           </a:xfrm>
           <a:prstGeom prst="rect">
             <a:avLst/>
           </a:prstGeom>
           <a:noFill/>
+          <a:effectLst/>
         </p:spPr>
         <p:txBody>
           <a:bodyPr wrap="none" lIns="0" rIns="0" tIns="0" bIns="0">
@@ -10908,6 +11030,7 @@
               <a:srgbClr val="5B6676"/>
             </a:solidFill>
           </a:ln>
+          <a:effectLst/>
         </p:spPr>
         <p:style>
           <a:lnRef idx="1">
@@ -10973,6 +11096,7 @@
             <a:tailEnd type="triangle"/>
             <a:prstDash val="dash"/>
           </a:ln>
+          <a:effectLst/>
         </p:spPr>
         <p:style>
           <a:lnRef idx="2">
@@ -10997,13 +11121,14 @@
         </p:nvSpPr>
         <p:spPr>
           <a:xfrm>
-            <a:off x="9036000" y="5103000"/>
-            <a:ext cx="840000" cy="146000"/>
+            <a:off x="9332700" y="5197900"/>
+            <a:ext cx="190500" cy="80300"/>
           </a:xfrm>
           <a:prstGeom prst="rect">
             <a:avLst/>
           </a:prstGeom>
           <a:noFill/>
+          <a:effectLst/>
         </p:spPr>
         <p:txBody>
           <a:bodyPr wrap="none" lIns="0" rIns="0" tIns="0" bIns="0">
@@ -11046,6 +11171,7 @@
               <a:srgbClr val="5B6676"/>
             </a:solidFill>
           </a:ln>
+          <a:effectLst/>
         </p:spPr>
         <p:style>
           <a:lnRef idx="1">
@@ -11112,6 +11238,7 @@
               <a:srgbClr val="141C26"/>
             </a:solidFill>
           </a:ln>
+          <a:effectLst/>
         </p:spPr>
         <p:style>
           <a:lnRef idx="1">
@@ -11164,6 +11291,7 @@
             </a:solidFill>
             <a:tailEnd type="triangle"/>
           </a:ln>
+          <a:effectLst/>
         </p:spPr>
         <p:style>
           <a:lnRef idx="2">
@@ -11202,6 +11330,7 @@
               <a:srgbClr val="B4530B"/>
             </a:solidFill>
           </a:ln>
+          <a:effectLst/>
         </p:spPr>
         <p:style>
           <a:lnRef idx="1">
@@ -11269,6 +11398,7 @@
             </a:solidFill>
             <a:prstDash val="dash"/>
           </a:ln>
+          <a:effectLst/>
         </p:spPr>
         <p:style>
           <a:lnRef idx="1">
@@ -11323,6 +11453,7 @@
               <a:srgbClr val="2B55C7"/>
             </a:solidFill>
           </a:ln>
+          <a:effectLst/>
         </p:spPr>
         <p:style>
           <a:lnRef idx="1">
@@ -11387,6 +11518,7 @@
             </a:solidFill>
             <a:tailEnd type="triangle"/>
           </a:ln>
+          <a:effectLst/>
         </p:spPr>
         <p:style>
           <a:lnRef idx="2">
@@ -11423,6 +11555,7 @@
             </a:solidFill>
             <a:tailEnd type="triangle"/>
           </a:ln>
+          <a:effectLst/>
         </p:spPr>
         <p:style>
           <a:lnRef idx="2">
@@ -11460,6 +11593,7 @@
             <a:tailEnd type="triangle"/>
             <a:prstDash val="dash"/>
           </a:ln>
+          <a:effectLst/>
         </p:spPr>
         <p:style>
           <a:lnRef idx="2">
@@ -11484,13 +11618,14 @@
         </p:nvSpPr>
         <p:spPr>
           <a:xfrm>
-            <a:off x="10464000" y="5103000"/>
-            <a:ext cx="840000" cy="146000"/>
+            <a:off x="10808400" y="5197900"/>
+            <a:ext cx="190500" cy="80300"/>
           </a:xfrm>
           <a:prstGeom prst="rect">
             <a:avLst/>
           </a:prstGeom>
           <a:noFill/>
+          <a:effectLst/>
         </p:spPr>
         <p:txBody>
           <a:bodyPr wrap="none" lIns="0" rIns="0" tIns="0" bIns="0">
@@ -11533,6 +11668,7 @@
               <a:srgbClr val="5B6676"/>
             </a:solidFill>
           </a:ln>
+          <a:effectLst/>
         </p:spPr>
         <p:style>
           <a:lnRef idx="1">
@@ -11585,6 +11721,7 @@
           <a:ln>
             <a:noFill/>
           </a:ln>
+          <a:effectLst/>
         </p:spPr>
         <p:style>
           <a:lnRef idx="1">
@@ -11623,6 +11760,7 @@
             <a:avLst/>
           </a:prstGeom>
           <a:noFill/>
+          <a:effectLst/>
         </p:spPr>
         <p:txBody>
           <a:bodyPr wrap="none" lIns="0" rIns="0" tIns="0" bIns="0">
@@ -11673,6 +11811,7 @@
           <a:ln>
             <a:noFill/>
           </a:ln>
+          <a:effectLst/>
         </p:spPr>
         <p:style>
           <a:lnRef idx="1">
@@ -11711,6 +11850,7 @@
             <a:avLst/>
           </a:prstGeom>
           <a:noFill/>
+          <a:effectLst/>
         </p:spPr>
         <p:txBody>
           <a:bodyPr wrap="none" lIns="0" rIns="0" tIns="0" bIns="0">
@@ -11763,6 +11903,7 @@
           <a:ln>
             <a:noFill/>
           </a:ln>
+          <a:effectLst/>
         </p:spPr>
         <p:style>
           <a:lnRef idx="1">
@@ -11801,6 +11942,7 @@
             <a:avLst/>
           </a:prstGeom>
           <a:noFill/>
+          <a:effectLst/>
         </p:spPr>
         <p:txBody>
           <a:bodyPr wrap="none" lIns="0" rIns="0" tIns="0" bIns="0">
@@ -11853,6 +11995,7 @@
           <a:ln>
             <a:noFill/>
           </a:ln>
+          <a:effectLst/>
         </p:spPr>
         <p:style>
           <a:lnRef idx="1">
@@ -11891,6 +12034,7 @@
             <a:avLst/>
           </a:prstGeom>
           <a:noFill/>
+          <a:effectLst/>
         </p:spPr>
         <p:txBody>
           <a:bodyPr wrap="none" lIns="0" rIns="0" tIns="0" bIns="0">
@@ -11945,6 +12089,7 @@
               <a:srgbClr val="2B55C7"/>
             </a:solidFill>
           </a:ln>
+          <a:effectLst/>
         </p:spPr>
         <p:style>
           <a:lnRef idx="1">
@@ -11983,6 +12128,7 @@
             <a:avLst/>
           </a:prstGeom>
           <a:noFill/>
+          <a:effectLst/>
         </p:spPr>
         <p:txBody>
           <a:bodyPr wrap="none" lIns="0" rIns="0" tIns="0" bIns="0">
@@ -12037,6 +12183,7 @@
               <a:srgbClr val="2B55C7"/>
             </a:solidFill>
           </a:ln>
+          <a:effectLst/>
         </p:spPr>
         <p:style>
           <a:lnRef idx="1">
@@ -12075,6 +12222,7 @@
             <a:avLst/>
           </a:prstGeom>
           <a:noFill/>
+          <a:effectLst/>
         </p:spPr>
         <p:txBody>
           <a:bodyPr wrap="none" lIns="0" rIns="0" tIns="0" bIns="0">
@@ -12148,6 +12296,7 @@
             <a:avLst/>
           </a:prstGeom>
           <a:noFill/>
+          <a:effectLst/>
         </p:spPr>
         <p:txBody>
           <a:bodyPr wrap="square" lIns="0" tIns="0" rIns="0" bIns="0">
@@ -12205,6 +12354,7 @@
               <a:srgbClr val="CFD6DF"/>
             </a:solidFill>
           </a:ln>
+          <a:effectLst/>
         </p:spPr>
         <p:style>
           <a:lnRef idx="1">
@@ -12363,6 +12513,7 @@
               <a:srgbClr val="CFD6DF"/>
             </a:solidFill>
           </a:ln>
+          <a:effectLst/>
         </p:spPr>
         <p:style>
           <a:lnRef idx="1">
@@ -12521,6 +12672,7 @@
               <a:srgbClr val="B4530B"/>
             </a:solidFill>
           </a:ln>
+          <a:effectLst/>
         </p:spPr>
         <p:style>
           <a:lnRef idx="1">
@@ -12603,6 +12755,7 @@
             <a:avLst/>
           </a:prstGeom>
           <a:noFill/>
+          <a:effectLst/>
         </p:spPr>
         <p:txBody>
           <a:bodyPr wrap="square" lIns="0" tIns="0" rIns="0" bIns="0">
@@ -12660,6 +12813,7 @@
               <a:srgbClr val="CFD6DF"/>
             </a:solidFill>
           </a:ln>
+          <a:effectLst/>
         </p:spPr>
         <p:style>
           <a:lnRef idx="1">
@@ -12818,6 +12972,7 @@
               <a:srgbClr val="CFD6DF"/>
             </a:solidFill>
           </a:ln>
+          <a:effectLst/>
         </p:spPr>
         <p:style>
           <a:lnRef idx="1">
@@ -12976,6 +13131,7 @@
               <a:srgbClr val="2B55C7"/>
             </a:solidFill>
           </a:ln>
+          <a:effectLst/>
         </p:spPr>
         <p:style>
           <a:lnRef idx="1">
@@ -13058,6 +13214,7 @@
             <a:avLst/>
           </a:prstGeom>
           <a:noFill/>
+          <a:effectLst/>
         </p:spPr>
         <p:txBody>
           <a:bodyPr wrap="square" lIns="0" tIns="0" rIns="0" bIns="0">
@@ -13115,6 +13272,7 @@
               <a:srgbClr val="CFD6DF"/>
             </a:solidFill>
           </a:ln>
+          <a:effectLst/>
         </p:spPr>
         <p:style>
           <a:lnRef idx="1">
@@ -13189,6 +13347,7 @@
               <a:srgbClr val="CFD6DF"/>
             </a:solidFill>
           </a:ln>
+          <a:effectLst/>
         </p:spPr>
         <p:style>
           <a:lnRef idx="1">
@@ -13263,6 +13422,7 @@
               <a:srgbClr val="CFD6DF"/>
             </a:solidFill>
           </a:ln>
+          <a:effectLst/>
         </p:spPr>
         <p:style>
           <a:lnRef idx="1">
@@ -13337,6 +13497,7 @@
               <a:srgbClr val="2B55C7"/>
             </a:solidFill>
           </a:ln>
+          <a:effectLst/>
         </p:spPr>
         <p:style>
           <a:lnRef idx="1">
@@ -13384,6 +13545,7 @@
             <a:avLst/>
           </a:prstGeom>
           <a:noFill/>
+          <a:effectLst/>
         </p:spPr>
         <p:txBody>
           <a:bodyPr wrap="square">
@@ -13444,6 +13606,7 @@
             <a:avLst/>
           </a:prstGeom>
           <a:noFill/>
+          <a:effectLst/>
         </p:spPr>
         <p:txBody>
           <a:bodyPr wrap="square" lIns="0" tIns="0" rIns="0" bIns="0">
@@ -13501,6 +13664,7 @@
               <a:srgbClr val="CFD6DF"/>
             </a:solidFill>
           </a:ln>
+          <a:effectLst/>
         </p:spPr>
         <p:style>
           <a:lnRef idx="1">
@@ -13659,6 +13823,7 @@
               <a:srgbClr val="CFD6DF"/>
             </a:solidFill>
           </a:ln>
+          <a:effectLst/>
         </p:spPr>
         <p:style>
           <a:lnRef idx="1">
@@ -13817,6 +13982,7 @@
               <a:srgbClr val="B4530B"/>
             </a:solidFill>
           </a:ln>
+          <a:effectLst/>
         </p:spPr>
         <p:style>
           <a:lnRef idx="1">
@@ -13899,6 +14065,7 @@
             <a:avLst/>
           </a:prstGeom>
           <a:noFill/>
+          <a:effectLst/>
         </p:spPr>
         <p:txBody>
           <a:bodyPr wrap="square" lIns="0" tIns="0" rIns="0" bIns="0">
@@ -13956,6 +14123,7 @@
               <a:srgbClr val="CFD6DF"/>
             </a:solidFill>
           </a:ln>
+          <a:effectLst/>
         </p:spPr>
         <p:style>
           <a:lnRef idx="1">
@@ -14139,6 +14307,7 @@
               <a:srgbClr val="CFD6DF"/>
             </a:solidFill>
           </a:ln>
+          <a:effectLst/>
         </p:spPr>
         <p:style>
           <a:lnRef idx="1">
@@ -14184,6 +14353,7 @@
               <a:srgbClr val="2B55C7"/>
             </a:solidFill>
           </a:ln>
+          <a:effectLst/>
         </p:spPr>
         <p:style>
           <a:lnRef idx="1">
@@ -14238,6 +14408,7 @@
               <a:srgbClr val="2B55C7"/>
             </a:solidFill>
           </a:ln>
+          <a:effectLst/>
         </p:spPr>
         <p:style>
           <a:lnRef idx="1">
@@ -14292,6 +14463,7 @@
               <a:srgbClr val="2B55C7"/>
             </a:solidFill>
           </a:ln>
+          <a:effectLst/>
         </p:spPr>
         <p:style>
           <a:lnRef idx="1">
@@ -14346,6 +14518,7 @@
               <a:srgbClr val="B4530B"/>
             </a:solidFill>
           </a:ln>
+          <a:effectLst/>
         </p:spPr>
         <p:style>
           <a:lnRef idx="1">
@@ -14400,6 +14573,7 @@
               <a:srgbClr val="B4530B"/>
             </a:solidFill>
           </a:ln>
+          <a:effectLst/>
         </p:spPr>
         <p:style>
           <a:lnRef idx="1">
@@ -14454,6 +14628,7 @@
               <a:srgbClr val="2B55C7"/>
             </a:solidFill>
           </a:ln>
+          <a:effectLst/>
         </p:spPr>
         <p:style>
           <a:lnRef idx="1">
@@ -14506,6 +14681,7 @@
             </a:solidFill>
             <a:tailEnd type="triangle"/>
           </a:ln>
+          <a:effectLst/>
         </p:spPr>
         <p:style>
           <a:lnRef idx="2">
@@ -14530,13 +14706,14 @@
         </p:nvSpPr>
         <p:spPr>
           <a:xfrm>
-            <a:off x="8448000" y="1928000"/>
-            <a:ext cx="896000" cy="304000"/>
+            <a:off x="8743600" y="2004000"/>
+            <a:ext cx="304800" cy="182400"/>
           </a:xfrm>
           <a:prstGeom prst="rect">
             <a:avLst/>
           </a:prstGeom>
           <a:noFill/>
+          <a:effectLst/>
         </p:spPr>
         <p:txBody>
           <a:bodyPr wrap="none" lIns="0" rIns="0" tIns="0" bIns="0">
@@ -14577,6 +14754,7 @@
             </a:solidFill>
             <a:tailEnd type="triangle"/>
           </a:ln>
+          <a:effectLst/>
         </p:spPr>
         <p:style>
           <a:lnRef idx="2">
@@ -14601,13 +14779,14 @@
         </p:nvSpPr>
         <p:spPr>
           <a:xfrm>
-            <a:off x="10128000" y="2688000"/>
-            <a:ext cx="896000" cy="304000"/>
+            <a:off x="10240000" y="2794400"/>
+            <a:ext cx="406400" cy="182400"/>
           </a:xfrm>
           <a:prstGeom prst="rect">
             <a:avLst/>
           </a:prstGeom>
           <a:noFill/>
+          <a:effectLst/>
         </p:spPr>
         <p:txBody>
           <a:bodyPr wrap="none" lIns="0" rIns="0" tIns="0" bIns="0">
@@ -14648,6 +14827,7 @@
             </a:solidFill>
             <a:tailEnd type="triangle"/>
           </a:ln>
+          <a:effectLst/>
         </p:spPr>
         <p:style>
           <a:lnRef idx="2">
@@ -14672,13 +14852,14 @@
         </p:nvSpPr>
         <p:spPr>
           <a:xfrm>
-            <a:off x="8492800" y="3250400"/>
-            <a:ext cx="896000" cy="304000"/>
+            <a:off x="8737600" y="3296000"/>
+            <a:ext cx="406400" cy="182400"/>
           </a:xfrm>
           <a:prstGeom prst="rect">
             <a:avLst/>
           </a:prstGeom>
           <a:noFill/>
+          <a:effectLst/>
         </p:spPr>
         <p:txBody>
           <a:bodyPr wrap="none" lIns="0" rIns="0" tIns="0" bIns="0">
@@ -14719,6 +14900,7 @@
             </a:solidFill>
             <a:tailEnd type="triangle"/>
           </a:ln>
+          <a:effectLst/>
         </p:spPr>
         <p:style>
           <a:lnRef idx="2">
@@ -14743,13 +14925,14 @@
         </p:nvSpPr>
         <p:spPr>
           <a:xfrm>
-            <a:off x="7384000" y="2809600"/>
-            <a:ext cx="896000" cy="304000"/>
+            <a:off x="7608000" y="2900800"/>
+            <a:ext cx="152400" cy="182400"/>
           </a:xfrm>
           <a:prstGeom prst="rect">
             <a:avLst/>
           </a:prstGeom>
           <a:noFill/>
+          <a:effectLst/>
         </p:spPr>
         <p:txBody>
           <a:bodyPr wrap="none" lIns="0" rIns="0" tIns="0" bIns="0">
@@ -14790,6 +14973,7 @@
             </a:solidFill>
             <a:tailEnd type="triangle"/>
           </a:ln>
+          <a:effectLst/>
         </p:spPr>
         <p:style>
           <a:lnRef idx="2">
@@ -14814,13 +14998,14 @@
         </p:nvSpPr>
         <p:spPr>
           <a:xfrm>
-            <a:off x="10296000" y="4025600"/>
-            <a:ext cx="896000" cy="304000"/>
+            <a:off x="10240000" y="4101600"/>
+            <a:ext cx="609600" cy="182400"/>
           </a:xfrm>
           <a:prstGeom prst="rect">
             <a:avLst/>
           </a:prstGeom>
           <a:noFill/>
+          <a:effectLst/>
         </p:spPr>
         <p:txBody>
           <a:bodyPr wrap="none" lIns="0" rIns="0" tIns="0" bIns="0">
@@ -14861,6 +15046,7 @@
             </a:solidFill>
             <a:tailEnd type="triangle"/>
           </a:ln>
+          <a:effectLst/>
         </p:spPr>
         <p:style>
           <a:lnRef idx="2">
@@ -14885,13 +15071,14 @@
         </p:nvSpPr>
         <p:spPr>
           <a:xfrm>
-            <a:off x="8616000" y="3980000"/>
-            <a:ext cx="896000" cy="304000"/>
+            <a:off x="9064000" y="4147200"/>
+            <a:ext cx="406400" cy="182400"/>
           </a:xfrm>
           <a:prstGeom prst="rect">
             <a:avLst/>
           </a:prstGeom>
           <a:noFill/>
+          <a:effectLst/>
         </p:spPr>
         <p:txBody>
           <a:bodyPr wrap="none" lIns="0" rIns="0" tIns="0" bIns="0">
@@ -14899,7 +15086,7 @@
           </a:bodyPr>
           <a:lstStyle/>
           <a:p>
-            <a:pPr algn="ctr"/>
+            <a:pPr algn="l"/>
             <a:r>
               <a:rPr sz="800">
                 <a:solidFill>
@@ -14932,6 +15119,7 @@
             </a:solidFill>
             <a:tailEnd type="triangle"/>
           </a:ln>
+          <a:effectLst/>
         </p:spPr>
         <p:style>
           <a:lnRef idx="2">
@@ -14956,13 +15144,14 @@
         </p:nvSpPr>
         <p:spPr>
           <a:xfrm>
-            <a:off x="7384000" y="4147200"/>
-            <a:ext cx="896000" cy="304000"/>
+            <a:off x="7608000" y="4253600"/>
+            <a:ext cx="254000" cy="182400"/>
           </a:xfrm>
           <a:prstGeom prst="rect">
             <a:avLst/>
           </a:prstGeom>
           <a:noFill/>
+          <a:effectLst/>
         </p:spPr>
         <p:txBody>
           <a:bodyPr wrap="none" lIns="0" rIns="0" tIns="0" bIns="0">
@@ -15024,6 +15213,7 @@
             <a:avLst/>
           </a:prstGeom>
           <a:noFill/>
+          <a:effectLst/>
         </p:spPr>
         <p:txBody>
           <a:bodyPr wrap="square" lIns="0" tIns="0" rIns="0" bIns="0">
@@ -15516,6 +15706,7 @@
               <a:srgbClr val="2B55C7"/>
             </a:solidFill>
           </a:ln>
+          <a:effectLst/>
         </p:spPr>
         <p:style>
           <a:lnRef idx="1">

</xml_diff>